<commit_message>
adjust the IOC setup instructions
</commit_message>
<xml_diff>
--- a/presentations/EPICS IOC setup.pptx
+++ b/presentations/EPICS IOC setup.pptx
@@ -12,13 +12,13 @@
   </p:handoutMasterIdLst>
   <p:sldIdLst>
     <p:sldId id="286" r:id="rId2"/>
-    <p:sldId id="293" r:id="rId3"/>
-    <p:sldId id="289" r:id="rId4"/>
-    <p:sldId id="290" r:id="rId5"/>
-    <p:sldId id="291" r:id="rId6"/>
+    <p:sldId id="289" r:id="rId3"/>
+    <p:sldId id="290" r:id="rId4"/>
+    <p:sldId id="291" r:id="rId5"/>
+    <p:sldId id="292" r:id="rId6"/>
     <p:sldId id="610" r:id="rId7"/>
     <p:sldId id="611" r:id="rId8"/>
-    <p:sldId id="292" r:id="rId9"/>
+    <p:sldId id="612" r:id="rId9"/>
     <p:sldId id="280" r:id="rId10"/>
   </p:sldIdLst>
   <p:sldSz cx="12192000" cy="6858000"/>
@@ -259,7 +259,7 @@
           <a:p>
             <a:fld id="{E00E58FE-3AE1-4995-80E6-8AF0F1DA0E4E}" type="datetimeFigureOut">
               <a:rPr lang="de-DE" smtClean="0"/>
-              <a:t>16.04.26</a:t>
+              <a:t>21.04.26</a:t>
             </a:fld>
             <a:endParaRPr lang="de-DE"/>
           </a:p>
@@ -436,7 +436,7 @@
           <a:p>
             <a:fld id="{45091381-FB9B-4B1C-99E3-890DFD4525D3}" type="datetimeFigureOut">
               <a:rPr lang="de-DE" smtClean="0"/>
-              <a:t>16.04.26</a:t>
+              <a:t>21.04.26</a:t>
             </a:fld>
             <a:endParaRPr lang="de-DE"/>
           </a:p>
@@ -722,6 +722,201 @@
       </p:grpSpPr>
       <p:sp>
         <p:nvSpPr>
+          <p:cNvPr id="2" name="Slide Image Placeholder 1"/>
+          <p:cNvSpPr>
+            <a:spLocks noGrp="1" noRot="1" noChangeAspect="1"/>
+          </p:cNvSpPr>
+          <p:nvPr>
+            <p:ph type="sldImg"/>
+          </p:nvPr>
+        </p:nvSpPr>
+        <p:spPr/>
+      </p:sp>
+      <p:sp>
+        <p:nvSpPr>
+          <p:cNvPr id="3" name="Notes Placeholder 2"/>
+          <p:cNvSpPr>
+            <a:spLocks noGrp="1"/>
+          </p:cNvSpPr>
+          <p:nvPr>
+            <p:ph type="body" idx="1"/>
+          </p:nvPr>
+        </p:nvSpPr>
+        <p:spPr/>
+        <p:txBody>
+          <a:bodyPr/>
+          <a:lstStyle/>
+          <a:p>
+            <a:endParaRPr lang="en-GB" dirty="0"/>
+          </a:p>
+        </p:txBody>
+      </p:sp>
+      <p:sp>
+        <p:nvSpPr>
+          <p:cNvPr id="4" name="Slide Number Placeholder 3"/>
+          <p:cNvSpPr>
+            <a:spLocks noGrp="1"/>
+          </p:cNvSpPr>
+          <p:nvPr>
+            <p:ph type="sldNum" sz="quarter" idx="5"/>
+          </p:nvPr>
+        </p:nvSpPr>
+        <p:spPr/>
+        <p:txBody>
+          <a:bodyPr/>
+          <a:lstStyle/>
+          <a:p>
+            <a:fld id="{64D9B650-A7F0-464D-8688-D88779A13E29}" type="slidenum">
+              <a:rPr lang="de-DE" smtClean="0"/>
+              <a:t>5</a:t>
+            </a:fld>
+            <a:endParaRPr lang="de-DE"/>
+          </a:p>
+        </p:txBody>
+      </p:sp>
+    </p:spTree>
+    <p:extLst>
+      <p:ext uri="{BB962C8B-B14F-4D97-AF65-F5344CB8AC3E}">
+        <p14:creationId xmlns:p14="http://schemas.microsoft.com/office/powerpoint/2010/main" val="2468240727"/>
+      </p:ext>
+    </p:extLst>
+  </p:cSld>
+  <p:clrMapOvr>
+    <a:masterClrMapping/>
+  </p:clrMapOvr>
+</p:notes>
+</file>
+
+<file path=ppt/notesSlides/notesSlide2.xml><?xml version="1.0" encoding="utf-8"?>
+<p:notes xmlns:a="http://schemas.openxmlformats.org/drawingml/2006/main" xmlns:r="http://schemas.openxmlformats.org/officeDocument/2006/relationships" xmlns:p="http://schemas.openxmlformats.org/presentationml/2006/main">
+  <p:cSld>
+    <p:spTree>
+      <p:nvGrpSpPr>
+        <p:cNvPr id="1" name="">
+          <a:extLst>
+            <a:ext uri="{FF2B5EF4-FFF2-40B4-BE49-F238E27FC236}">
+              <a16:creationId xmlns:a16="http://schemas.microsoft.com/office/drawing/2014/main" id="{A7517E75-33D1-338B-282D-ED000995224F}"/>
+            </a:ext>
+          </a:extLst>
+        </p:cNvPr>
+        <p:cNvGrpSpPr/>
+        <p:nvPr/>
+      </p:nvGrpSpPr>
+      <p:grpSpPr>
+        <a:xfrm>
+          <a:off x="0" y="0"/>
+          <a:ext cx="0" cy="0"/>
+          <a:chOff x="0" y="0"/>
+          <a:chExt cx="0" cy="0"/>
+        </a:xfrm>
+      </p:grpSpPr>
+      <p:sp>
+        <p:nvSpPr>
+          <p:cNvPr id="2" name="Slide Image Placeholder 1">
+            <a:extLst>
+              <a:ext uri="{FF2B5EF4-FFF2-40B4-BE49-F238E27FC236}">
+                <a16:creationId xmlns:a16="http://schemas.microsoft.com/office/drawing/2014/main" id="{7D2A63B7-4894-6DAA-288A-A287F2F1ECA9}"/>
+              </a:ext>
+            </a:extLst>
+          </p:cNvPr>
+          <p:cNvSpPr>
+            <a:spLocks noGrp="1" noRot="1" noChangeAspect="1"/>
+          </p:cNvSpPr>
+          <p:nvPr>
+            <p:ph type="sldImg"/>
+          </p:nvPr>
+        </p:nvSpPr>
+        <p:spPr/>
+      </p:sp>
+      <p:sp>
+        <p:nvSpPr>
+          <p:cNvPr id="3" name="Notes Placeholder 2">
+            <a:extLst>
+              <a:ext uri="{FF2B5EF4-FFF2-40B4-BE49-F238E27FC236}">
+                <a16:creationId xmlns:a16="http://schemas.microsoft.com/office/drawing/2014/main" id="{497C7B27-9F3B-22F2-B95A-8718EF1253C3}"/>
+              </a:ext>
+            </a:extLst>
+          </p:cNvPr>
+          <p:cNvSpPr>
+            <a:spLocks noGrp="1"/>
+          </p:cNvSpPr>
+          <p:nvPr>
+            <p:ph type="body" idx="1"/>
+          </p:nvPr>
+        </p:nvSpPr>
+        <p:spPr/>
+        <p:txBody>
+          <a:bodyPr/>
+          <a:lstStyle/>
+          <a:p>
+            <a:r>
+              <a:rPr lang="en-GB" dirty="0"/>
+              <a:t>The idea is to create a simple OPI that has the widgets to switch on the supply, set the output voltage and to monitor the output voltage.</a:t>
+            </a:r>
+          </a:p>
+        </p:txBody>
+      </p:sp>
+      <p:sp>
+        <p:nvSpPr>
+          <p:cNvPr id="4" name="Slide Number Placeholder 3">
+            <a:extLst>
+              <a:ext uri="{FF2B5EF4-FFF2-40B4-BE49-F238E27FC236}">
+                <a16:creationId xmlns:a16="http://schemas.microsoft.com/office/drawing/2014/main" id="{1DB03342-1287-C90A-75AD-86EE51B5FD7A}"/>
+              </a:ext>
+            </a:extLst>
+          </p:cNvPr>
+          <p:cNvSpPr>
+            <a:spLocks noGrp="1"/>
+          </p:cNvSpPr>
+          <p:nvPr>
+            <p:ph type="sldNum" sz="quarter" idx="5"/>
+          </p:nvPr>
+        </p:nvSpPr>
+        <p:spPr/>
+        <p:txBody>
+          <a:bodyPr/>
+          <a:lstStyle/>
+          <a:p>
+            <a:fld id="{64D9B650-A7F0-464D-8688-D88779A13E29}" type="slidenum">
+              <a:rPr lang="de-DE" smtClean="0"/>
+              <a:t>8</a:t>
+            </a:fld>
+            <a:endParaRPr lang="de-DE"/>
+          </a:p>
+        </p:txBody>
+      </p:sp>
+    </p:spTree>
+    <p:extLst>
+      <p:ext uri="{BB962C8B-B14F-4D97-AF65-F5344CB8AC3E}">
+        <p14:creationId xmlns:p14="http://schemas.microsoft.com/office/powerpoint/2010/main" val="3953750961"/>
+      </p:ext>
+    </p:extLst>
+  </p:cSld>
+  <p:clrMapOvr>
+    <a:masterClrMapping/>
+  </p:clrMapOvr>
+</p:notes>
+</file>
+
+<file path=ppt/notesSlides/notesSlide3.xml><?xml version="1.0" encoding="utf-8"?>
+<p:notes xmlns:a="http://schemas.openxmlformats.org/drawingml/2006/main" xmlns:r="http://schemas.openxmlformats.org/officeDocument/2006/relationships" xmlns:p="http://schemas.openxmlformats.org/presentationml/2006/main">
+  <p:cSld>
+    <p:spTree>
+      <p:nvGrpSpPr>
+        <p:cNvPr id="1" name=""/>
+        <p:cNvGrpSpPr/>
+        <p:nvPr/>
+      </p:nvGrpSpPr>
+      <p:grpSpPr>
+        <a:xfrm>
+          <a:off x="0" y="0"/>
+          <a:ext cx="0" cy="0"/>
+          <a:chOff x="0" y="0"/>
+          <a:chExt cx="0" cy="0"/>
+        </a:xfrm>
+      </p:grpSpPr>
+      <p:sp>
+        <p:nvSpPr>
           <p:cNvPr id="41986" name="Rectangle 1031"/>
           <p:cNvSpPr>
             <a:spLocks noGrp="1" noChangeArrowheads="1"/>
@@ -963,7 +1158,7 @@
           <a:p>
             <a:fld id="{77B9AAF2-2243-4209-A85C-F7036AF186DC}" type="datetimeFigureOut">
               <a:rPr lang="de-DE" smtClean="0"/>
-              <a:t>16.04.26</a:t>
+              <a:t>21.04.26</a:t>
             </a:fld>
             <a:endParaRPr lang="de-DE"/>
           </a:p>
@@ -1203,7 +1398,7 @@
           <a:p>
             <a:fld id="{77B9AAF2-2243-4209-A85C-F7036AF186DC}" type="datetimeFigureOut">
               <a:rPr lang="de-DE" smtClean="0"/>
-              <a:t>16.04.26</a:t>
+              <a:t>21.04.26</a:t>
             </a:fld>
             <a:endParaRPr lang="de-DE"/>
           </a:p>
@@ -1443,7 +1638,7 @@
           <a:p>
             <a:fld id="{77B9AAF2-2243-4209-A85C-F7036AF186DC}" type="datetimeFigureOut">
               <a:rPr lang="de-DE" smtClean="0"/>
-              <a:t>16.04.26</a:t>
+              <a:t>21.04.26</a:t>
             </a:fld>
             <a:endParaRPr lang="de-DE"/>
           </a:p>
@@ -1683,7 +1878,7 @@
           <a:p>
             <a:fld id="{77B9AAF2-2243-4209-A85C-F7036AF186DC}" type="datetimeFigureOut">
               <a:rPr lang="de-DE" smtClean="0"/>
-              <a:t>16.04.26</a:t>
+              <a:t>21.04.26</a:t>
             </a:fld>
             <a:endParaRPr lang="de-DE"/>
           </a:p>
@@ -1989,7 +2184,7 @@
           <a:p>
             <a:fld id="{77B9AAF2-2243-4209-A85C-F7036AF186DC}" type="datetimeFigureOut">
               <a:rPr lang="de-DE" smtClean="0"/>
-              <a:t>16.04.26</a:t>
+              <a:t>21.04.26</a:t>
             </a:fld>
             <a:endParaRPr lang="de-DE"/>
           </a:p>
@@ -2295,7 +2490,7 @@
           <a:p>
             <a:fld id="{77B9AAF2-2243-4209-A85C-F7036AF186DC}" type="datetimeFigureOut">
               <a:rPr lang="de-DE" smtClean="0"/>
-              <a:t>16.04.26</a:t>
+              <a:t>21.04.26</a:t>
             </a:fld>
             <a:endParaRPr lang="de-DE"/>
           </a:p>
@@ -2749,7 +2944,7 @@
           <a:p>
             <a:fld id="{77B9AAF2-2243-4209-A85C-F7036AF186DC}" type="datetimeFigureOut">
               <a:rPr lang="de-DE" smtClean="0"/>
-              <a:t>16.04.26</a:t>
+              <a:t>21.04.26</a:t>
             </a:fld>
             <a:endParaRPr lang="de-DE"/>
           </a:p>
@@ -2923,7 +3118,7 @@
           <a:p>
             <a:fld id="{77B9AAF2-2243-4209-A85C-F7036AF186DC}" type="datetimeFigureOut">
               <a:rPr lang="de-DE" smtClean="0"/>
-              <a:t>16.04.26</a:t>
+              <a:t>21.04.26</a:t>
             </a:fld>
             <a:endParaRPr lang="de-DE"/>
           </a:p>
@@ -3299,7 +3494,7 @@
           <a:p>
             <a:fld id="{77B9AAF2-2243-4209-A85C-F7036AF186DC}" type="datetimeFigureOut">
               <a:rPr lang="de-DE" smtClean="0"/>
-              <a:t>16.04.26</a:t>
+              <a:t>21.04.26</a:t>
             </a:fld>
             <a:endParaRPr lang="de-DE"/>
           </a:p>
@@ -3625,7 +3820,7 @@
           <a:p>
             <a:fld id="{77B9AAF2-2243-4209-A85C-F7036AF186DC}" type="datetimeFigureOut">
               <a:rPr lang="de-DE" smtClean="0"/>
-              <a:t>16.04.26</a:t>
+              <a:t>21.04.26</a:t>
             </a:fld>
             <a:endParaRPr lang="de-DE"/>
           </a:p>
@@ -4289,336 +4484,6 @@
   <p:cSld>
     <p:spTree>
       <p:nvGrpSpPr>
-        <p:cNvPr id="1" name="">
-          <a:extLst>
-            <a:ext uri="{FF2B5EF4-FFF2-40B4-BE49-F238E27FC236}">
-              <a16:creationId xmlns:a16="http://schemas.microsoft.com/office/drawing/2014/main" id="{C83654EA-77AB-A6AB-F11F-593E8F93DBD5}"/>
-            </a:ext>
-          </a:extLst>
-        </p:cNvPr>
-        <p:cNvGrpSpPr/>
-        <p:nvPr/>
-      </p:nvGrpSpPr>
-      <p:grpSpPr>
-        <a:xfrm>
-          <a:off x="0" y="0"/>
-          <a:ext cx="0" cy="0"/>
-          <a:chOff x="0" y="0"/>
-          <a:chExt cx="0" cy="0"/>
-        </a:xfrm>
-      </p:grpSpPr>
-      <p:sp>
-        <p:nvSpPr>
-          <p:cNvPr id="2" name="Textfeld 3">
-            <a:extLst>
-              <a:ext uri="{FF2B5EF4-FFF2-40B4-BE49-F238E27FC236}">
-                <a16:creationId xmlns:a16="http://schemas.microsoft.com/office/drawing/2014/main" id="{CAE218AF-A5D6-A3D0-03FB-7E97B060AF9B}"/>
-              </a:ext>
-            </a:extLst>
-          </p:cNvPr>
-          <p:cNvSpPr txBox="1"/>
-          <p:nvPr/>
-        </p:nvSpPr>
-        <p:spPr>
-          <a:xfrm>
-            <a:off x="1314628" y="456623"/>
-            <a:ext cx="9658172" cy="5530938"/>
-          </a:xfrm>
-          <a:prstGeom prst="rect">
-            <a:avLst/>
-          </a:prstGeom>
-          <a:noFill/>
-        </p:spPr>
-        <p:txBody>
-          <a:bodyPr wrap="square" lIns="0" tIns="0" rIns="0" bIns="0" rtlCol="0">
-            <a:spAutoFit/>
-          </a:bodyPr>
-          <a:lstStyle/>
-          <a:p>
-            <a:pPr eaLnBrk="0" hangingPunct="0">
-              <a:lnSpc>
-                <a:spcPct val="120000"/>
-              </a:lnSpc>
-              <a:spcAft>
-                <a:spcPts val="627"/>
-              </a:spcAft>
-              <a:buClr>
-                <a:srgbClr val="9C072D"/>
-              </a:buClr>
-              <a:tabLst>
-                <a:tab pos="392682" algn="l"/>
-              </a:tabLst>
-            </a:pPr>
-            <a:r>
-              <a:rPr lang="en-GB" sz="3200" b="1" noProof="0" dirty="0">
-                <a:solidFill>
-                  <a:srgbClr val="60737F"/>
-                </a:solidFill>
-                <a:latin typeface="Oswald Regular" panose="02000503000000000000" pitchFamily="2" charset="0"/>
-                <a:ea typeface="Milo-Medium"/>
-                <a:cs typeface="Source Sans Pro"/>
-              </a:rPr>
-              <a:t>Task: integrate a simple power supply using </a:t>
-            </a:r>
-            <a:r>
-              <a:rPr lang="en-GB" sz="3200" b="1" noProof="0" dirty="0" err="1">
-                <a:solidFill>
-                  <a:srgbClr val="60737F"/>
-                </a:solidFill>
-                <a:latin typeface="Oswald Regular" panose="02000503000000000000" pitchFamily="2" charset="0"/>
-                <a:ea typeface="Milo-Medium"/>
-                <a:cs typeface="Source Sans Pro"/>
-              </a:rPr>
-              <a:t>StreamDevice</a:t>
-            </a:r>
-            <a:endParaRPr lang="en-GB" sz="3200" b="1" noProof="0" dirty="0">
-              <a:solidFill>
-                <a:srgbClr val="60737F"/>
-              </a:solidFill>
-              <a:latin typeface="Oswald Regular" panose="02000503000000000000" pitchFamily="2" charset="0"/>
-              <a:ea typeface="Milo-Medium"/>
-              <a:cs typeface="Source Sans Pro"/>
-            </a:endParaRPr>
-          </a:p>
-          <a:p>
-            <a:pPr marL="342900" indent="-342900" eaLnBrk="0" hangingPunct="0">
-              <a:lnSpc>
-                <a:spcPct val="120000"/>
-              </a:lnSpc>
-              <a:spcAft>
-                <a:spcPts val="627"/>
-              </a:spcAft>
-              <a:buClr>
-                <a:srgbClr val="C7DE37"/>
-              </a:buClr>
-              <a:buFont typeface="Arial" panose="020B0604020202020204" pitchFamily="34" charset="0"/>
-              <a:buChar char="•"/>
-              <a:tabLst>
-                <a:tab pos="392682" algn="l"/>
-              </a:tabLst>
-            </a:pPr>
-            <a:r>
-              <a:rPr lang="en-GB" sz="2400" noProof="0" dirty="0">
-                <a:solidFill>
-                  <a:srgbClr val="60737F"/>
-                </a:solidFill>
-                <a:latin typeface="Source Sans Pro"/>
-                <a:ea typeface="Milo-Medium"/>
-                <a:cs typeface="Source Sans Pro"/>
-              </a:rPr>
-              <a:t>This demo/exercise will show you the “barebones” method of setting up an IOC.</a:t>
-            </a:r>
-          </a:p>
-          <a:p>
-            <a:pPr marL="800100" lvl="1" indent="-342900" eaLnBrk="0" hangingPunct="0">
-              <a:lnSpc>
-                <a:spcPct val="120000"/>
-              </a:lnSpc>
-              <a:spcAft>
-                <a:spcPts val="627"/>
-              </a:spcAft>
-              <a:buClr>
-                <a:srgbClr val="C7DE37"/>
-              </a:buClr>
-              <a:buFont typeface="Arial" panose="020B0604020202020204" pitchFamily="34" charset="0"/>
-              <a:buChar char="•"/>
-              <a:tabLst>
-                <a:tab pos="392682" algn="l"/>
-              </a:tabLst>
-            </a:pPr>
-            <a:r>
-              <a:rPr lang="en-GB" sz="2400" dirty="0">
-                <a:solidFill>
-                  <a:srgbClr val="60737F"/>
-                </a:solidFill>
-                <a:latin typeface="Source Sans Pro"/>
-                <a:ea typeface="Milo-Medium"/>
-                <a:cs typeface="Source Sans Pro"/>
-              </a:rPr>
-              <a:t>Don’t be too scared. It gives you an idea what is behind the scenes.</a:t>
-            </a:r>
-            <a:endParaRPr lang="en-GB" sz="2400" noProof="0" dirty="0">
-              <a:solidFill>
-                <a:srgbClr val="60737F"/>
-              </a:solidFill>
-              <a:latin typeface="Source Sans Pro"/>
-              <a:ea typeface="Milo-Medium"/>
-              <a:cs typeface="Source Sans Pro"/>
-            </a:endParaRPr>
-          </a:p>
-          <a:p>
-            <a:pPr marL="342900" indent="-342900" eaLnBrk="0" hangingPunct="0">
-              <a:lnSpc>
-                <a:spcPct val="120000"/>
-              </a:lnSpc>
-              <a:spcAft>
-                <a:spcPts val="627"/>
-              </a:spcAft>
-              <a:buClr>
-                <a:srgbClr val="C7DE37"/>
-              </a:buClr>
-              <a:buFont typeface="Arial" panose="020B0604020202020204" pitchFamily="34" charset="0"/>
-              <a:buChar char="•"/>
-              <a:tabLst>
-                <a:tab pos="392682" algn="l"/>
-              </a:tabLst>
-            </a:pPr>
-            <a:r>
-              <a:rPr lang="en-GB" sz="2400" dirty="0">
-                <a:solidFill>
-                  <a:srgbClr val="60737F"/>
-                </a:solidFill>
-                <a:latin typeface="Source Sans Pro"/>
-                <a:ea typeface="Milo-Medium"/>
-                <a:cs typeface="Source Sans Pro"/>
-              </a:rPr>
-              <a:t>The community does not (yet) provide a common, universal setup tool.</a:t>
-            </a:r>
-          </a:p>
-          <a:p>
-            <a:pPr marL="800100" lvl="1" indent="-342900" eaLnBrk="0" hangingPunct="0">
-              <a:lnSpc>
-                <a:spcPct val="120000"/>
-              </a:lnSpc>
-              <a:spcAft>
-                <a:spcPts val="627"/>
-              </a:spcAft>
-              <a:buClr>
-                <a:srgbClr val="C7DE37"/>
-              </a:buClr>
-              <a:buFont typeface="Arial" panose="020B0604020202020204" pitchFamily="34" charset="0"/>
-              <a:buChar char="•"/>
-              <a:tabLst>
-                <a:tab pos="392682" algn="l"/>
-              </a:tabLst>
-            </a:pPr>
-            <a:r>
-              <a:rPr lang="en-GB" sz="2400" dirty="0">
-                <a:solidFill>
-                  <a:srgbClr val="60737F"/>
-                </a:solidFill>
-                <a:latin typeface="Source Sans Pro"/>
-                <a:ea typeface="Milo-Medium"/>
-                <a:cs typeface="Source Sans Pro"/>
-              </a:rPr>
-              <a:t>Several institutes have built their own environments to make this easier.</a:t>
-            </a:r>
-          </a:p>
-          <a:p>
-            <a:pPr marL="1257300" lvl="2" indent="-342900" eaLnBrk="0" hangingPunct="0">
-              <a:lnSpc>
-                <a:spcPct val="120000"/>
-              </a:lnSpc>
-              <a:spcAft>
-                <a:spcPts val="627"/>
-              </a:spcAft>
-              <a:buClr>
-                <a:srgbClr val="C7DE37"/>
-              </a:buClr>
-              <a:buFont typeface="Arial" panose="020B0604020202020204" pitchFamily="34" charset="0"/>
-              <a:buChar char="•"/>
-              <a:tabLst>
-                <a:tab pos="392682" algn="l"/>
-              </a:tabLst>
-            </a:pPr>
-            <a:r>
-              <a:rPr lang="en-GB" sz="2400" dirty="0">
-                <a:solidFill>
-                  <a:srgbClr val="60737F"/>
-                </a:solidFill>
-                <a:latin typeface="Source Sans Pro"/>
-                <a:ea typeface="Milo-Medium"/>
-                <a:cs typeface="Source Sans Pro"/>
-              </a:rPr>
-              <a:t>For instance our (ESS) build and management tool, the e3.</a:t>
-            </a:r>
-          </a:p>
-          <a:p>
-            <a:pPr marL="800100" lvl="1" indent="-342900" eaLnBrk="0" hangingPunct="0">
-              <a:lnSpc>
-                <a:spcPct val="120000"/>
-              </a:lnSpc>
-              <a:spcAft>
-                <a:spcPts val="627"/>
-              </a:spcAft>
-              <a:buClr>
-                <a:srgbClr val="C7DE37"/>
-              </a:buClr>
-              <a:buFont typeface="Arial" panose="020B0604020202020204" pitchFamily="34" charset="0"/>
-              <a:buChar char="•"/>
-              <a:tabLst>
-                <a:tab pos="392682" algn="l"/>
-              </a:tabLst>
-            </a:pPr>
-            <a:r>
-              <a:rPr lang="en-GB" sz="2400" dirty="0">
-                <a:solidFill>
-                  <a:srgbClr val="60737F"/>
-                </a:solidFill>
-                <a:latin typeface="Source Sans Pro"/>
-                <a:ea typeface="Milo-Medium"/>
-                <a:cs typeface="Source Sans Pro"/>
-              </a:rPr>
-              <a:t>For this simple setup I decided to use the off-the-box method.</a:t>
-            </a:r>
-          </a:p>
-          <a:p>
-            <a:pPr marL="342900" indent="-342900" eaLnBrk="0" hangingPunct="0">
-              <a:lnSpc>
-                <a:spcPct val="120000"/>
-              </a:lnSpc>
-              <a:spcAft>
-                <a:spcPts val="627"/>
-              </a:spcAft>
-              <a:buClr>
-                <a:srgbClr val="C7DE37"/>
-              </a:buClr>
-              <a:buFont typeface="Arial" panose="020B0604020202020204" pitchFamily="34" charset="0"/>
-              <a:buChar char="•"/>
-              <a:tabLst>
-                <a:tab pos="392682" algn="l"/>
-              </a:tabLst>
-            </a:pPr>
-            <a:r>
-              <a:rPr lang="en-GB" sz="2400" dirty="0">
-                <a:solidFill>
-                  <a:srgbClr val="60737F"/>
-                </a:solidFill>
-                <a:latin typeface="Source Sans Pro"/>
-                <a:ea typeface="Milo-Medium"/>
-                <a:cs typeface="Source Sans Pro"/>
-              </a:rPr>
-              <a:t>The site docs.epics-controls.org  has a couple of “getting started” recipes.</a:t>
-            </a:r>
-            <a:endParaRPr lang="en-GB" sz="2400" noProof="0" dirty="0">
-              <a:solidFill>
-                <a:srgbClr val="60737F"/>
-              </a:solidFill>
-              <a:latin typeface="Source Sans Pro"/>
-              <a:ea typeface="Milo-Medium"/>
-              <a:cs typeface="Source Sans Pro"/>
-            </a:endParaRPr>
-          </a:p>
-        </p:txBody>
-      </p:sp>
-    </p:spTree>
-    <p:extLst>
-      <p:ext uri="{BB962C8B-B14F-4D97-AF65-F5344CB8AC3E}">
-        <p14:creationId xmlns:p14="http://schemas.microsoft.com/office/powerpoint/2010/main" val="549251243"/>
-      </p:ext>
-    </p:extLst>
-  </p:cSld>
-  <p:clrMapOvr>
-    <a:masterClrMapping/>
-  </p:clrMapOvr>
-</p:sld>
-</file>
-
-<file path=ppt/slides/slide3.xml><?xml version="1.0" encoding="utf-8"?>
-<p:sld xmlns:a="http://schemas.openxmlformats.org/drawingml/2006/main" xmlns:r="http://schemas.openxmlformats.org/officeDocument/2006/relationships" xmlns:p="http://schemas.openxmlformats.org/presentationml/2006/main">
-  <p:cSld>
-    <p:spTree>
-      <p:nvGrpSpPr>
         <p:cNvPr id="1" name=""/>
         <p:cNvGrpSpPr/>
         <p:nvPr/>
@@ -4862,7 +4727,7 @@
 </p:sld>
 </file>
 
-<file path=ppt/slides/slide4.xml><?xml version="1.0" encoding="utf-8"?>
+<file path=ppt/slides/slide3.xml><?xml version="1.0" encoding="utf-8"?>
 <p:sld xmlns:a="http://schemas.openxmlformats.org/drawingml/2006/main" xmlns:r="http://schemas.openxmlformats.org/officeDocument/2006/relationships" xmlns:p="http://schemas.openxmlformats.org/presentationml/2006/main">
   <p:cSld>
     <p:spTree>
@@ -5144,7 +5009,7 @@
 </p:sld>
 </file>
 
-<file path=ppt/slides/slide5.xml><?xml version="1.0" encoding="utf-8"?>
+<file path=ppt/slides/slide4.xml><?xml version="1.0" encoding="utf-8"?>
 <p:sld xmlns:a="http://schemas.openxmlformats.org/drawingml/2006/main" xmlns:r="http://schemas.openxmlformats.org/officeDocument/2006/relationships" xmlns:p="http://schemas.openxmlformats.org/presentationml/2006/main">
   <p:cSld>
     <p:spTree>
@@ -5182,7 +5047,7 @@
         <p:spPr>
           <a:xfrm>
             <a:off x="1314628" y="456623"/>
-            <a:ext cx="9283883" cy="5453994"/>
+            <a:ext cx="9283883" cy="5530938"/>
           </a:xfrm>
           <a:prstGeom prst="rect">
             <a:avLst/>
@@ -5266,7 +5131,7 @@
                 <a:ea typeface="Milo-Medium"/>
                 <a:cs typeface="Source Sans Pro"/>
               </a:rPr>
-              <a:t>Before starting the VM:</a:t>
+              <a:t>Start the VM:</a:t>
             </a:r>
           </a:p>
           <a:p>
@@ -5295,7 +5160,7 @@
                 <a:ea typeface="Milo-Medium"/>
                 <a:cs typeface="Source Sans Pro"/>
               </a:rPr>
-              <a:t>In the “Extras” folder that you copied from the USB, there is a directory “</a:t>
+              <a:t>The “training/</a:t>
             </a:r>
             <a:r>
               <a:rPr lang="en-GB" sz="2400" dirty="0" err="1">
@@ -5306,7 +5171,7 @@
                 <a:ea typeface="Milo-Medium"/>
                 <a:cs typeface="Source Sans Pro"/>
               </a:rPr>
-              <a:t>streamIOC</a:t>
+              <a:t>streamdevice</a:t>
             </a:r>
             <a:r>
               <a:rPr lang="en-GB" sz="2400" dirty="0">
@@ -5317,27 +5182,8 @@
                 <a:ea typeface="Milo-Medium"/>
                 <a:cs typeface="Source Sans Pro"/>
               </a:rPr>
-              <a:t>”. It contains a ready-made IOC for communicating with the simulated power supply. In the VM settings, map that directory to /</a:t>
-            </a:r>
-            <a:r>
-              <a:rPr lang="en-GB" sz="2400" dirty="0" err="1">
-                <a:solidFill>
-                  <a:srgbClr val="60737F"/>
-                </a:solidFill>
-                <a:latin typeface="Source Sans Pro"/>
-                <a:ea typeface="Milo-Medium"/>
-                <a:cs typeface="Source Sans Pro"/>
-              </a:rPr>
-              <a:t>mnt</a:t>
-            </a:r>
-            <a:endParaRPr lang="en-GB" sz="2400" dirty="0">
-              <a:solidFill>
-                <a:srgbClr val="60737F"/>
-              </a:solidFill>
-              <a:latin typeface="Source Sans Pro"/>
-              <a:ea typeface="Milo-Medium"/>
-              <a:cs typeface="Source Sans Pro"/>
-            </a:endParaRPr>
+              <a:t>-introduction” folder contains an IOC setup that has been prepared to communicate with the simulated power supply.</a:t>
+            </a:r>
           </a:p>
           <a:p>
             <a:pPr marL="342900" indent="-342900" eaLnBrk="0" hangingPunct="0">
@@ -5365,29 +5211,7 @@
                 <a:ea typeface="Milo-Medium"/>
                 <a:cs typeface="Source Sans Pro"/>
               </a:rPr>
-              <a:t>Power up the VM. With the file manager, navigate to /</a:t>
-            </a:r>
-            <a:r>
-              <a:rPr lang="en-GB" sz="2400" dirty="0" err="1">
-                <a:solidFill>
-                  <a:srgbClr val="60737F"/>
-                </a:solidFill>
-                <a:latin typeface="Source Sans Pro"/>
-                <a:ea typeface="Milo-Medium"/>
-                <a:cs typeface="Source Sans Pro"/>
-              </a:rPr>
-              <a:t>mnt</a:t>
-            </a:r>
-            <a:r>
-              <a:rPr lang="en-GB" sz="2400" dirty="0">
-                <a:solidFill>
-                  <a:srgbClr val="60737F"/>
-                </a:solidFill>
-                <a:latin typeface="Source Sans Pro"/>
-                <a:ea typeface="Milo-Medium"/>
-                <a:cs typeface="Source Sans Pro"/>
-              </a:rPr>
-              <a:t>, and open a terminal there. (two or three windows or tabs will be needed.)</a:t>
+              <a:t>Change to that directory and open a terminal. (two or three windows or tabs will be needed.)</a:t>
             </a:r>
           </a:p>
           <a:p>
@@ -5416,6 +5240,57 @@
                 <a:ea typeface="Milo-Medium"/>
                 <a:cs typeface="Source Sans Pro"/>
               </a:rPr>
+              <a:t>Compile the </a:t>
+            </a:r>
+            <a:r>
+              <a:rPr lang="en-GB" sz="2400" dirty="0" err="1">
+                <a:solidFill>
+                  <a:srgbClr val="60737F"/>
+                </a:solidFill>
+                <a:latin typeface="Source Sans Pro"/>
+                <a:ea typeface="Milo-Medium"/>
+                <a:cs typeface="Source Sans Pro"/>
+              </a:rPr>
+              <a:t>ioc</a:t>
+            </a:r>
+            <a:r>
+              <a:rPr lang="en-GB" sz="2400" dirty="0">
+                <a:solidFill>
+                  <a:srgbClr val="60737F"/>
+                </a:solidFill>
+                <a:latin typeface="Source Sans Pro"/>
+                <a:ea typeface="Milo-Medium"/>
+                <a:cs typeface="Source Sans Pro"/>
+              </a:rPr>
+              <a:t> by typing make. </a:t>
+            </a:r>
+          </a:p>
+          <a:p>
+            <a:pPr marL="342900" indent="-342900" eaLnBrk="0" hangingPunct="0">
+              <a:lnSpc>
+                <a:spcPct val="120000"/>
+              </a:lnSpc>
+              <a:spcAft>
+                <a:spcPts val="627"/>
+              </a:spcAft>
+              <a:buClr>
+                <a:srgbClr val="C7DE37"/>
+              </a:buClr>
+              <a:buFont typeface="Arial" panose="020B0604020202020204" pitchFamily="34" charset="0"/>
+              <a:buChar char="•"/>
+              <a:tabLst>
+                <a:tab pos="392682" algn="l"/>
+              </a:tabLst>
+            </a:pPr>
+            <a:r>
+              <a:rPr lang="en-GB" sz="2400" dirty="0">
+                <a:solidFill>
+                  <a:srgbClr val="60737F"/>
+                </a:solidFill>
+                <a:latin typeface="Source Sans Pro"/>
+                <a:ea typeface="Milo-Medium"/>
+                <a:cs typeface="Source Sans Pro"/>
+              </a:rPr>
               <a:t>In one terminal window, start the simulator with:</a:t>
             </a:r>
           </a:p>
@@ -5524,6 +5399,599 @@
     <p:extLst>
       <p:ext uri="{BB962C8B-B14F-4D97-AF65-F5344CB8AC3E}">
         <p14:creationId xmlns:p14="http://schemas.microsoft.com/office/powerpoint/2010/main" val="3116630710"/>
+      </p:ext>
+    </p:extLst>
+  </p:cSld>
+  <p:clrMapOvr>
+    <a:masterClrMapping/>
+  </p:clrMapOvr>
+</p:sld>
+</file>
+
+<file path=ppt/slides/slide5.xml><?xml version="1.0" encoding="utf-8"?>
+<p:sld xmlns:a="http://schemas.openxmlformats.org/drawingml/2006/main" xmlns:r="http://schemas.openxmlformats.org/officeDocument/2006/relationships" xmlns:p="http://schemas.openxmlformats.org/presentationml/2006/main">
+  <p:cSld>
+    <p:spTree>
+      <p:nvGrpSpPr>
+        <p:cNvPr id="1" name="">
+          <a:extLst>
+            <a:ext uri="{FF2B5EF4-FFF2-40B4-BE49-F238E27FC236}">
+              <a16:creationId xmlns:a16="http://schemas.microsoft.com/office/drawing/2014/main" id="{CB5A8C0B-B17A-2F4F-CB49-FF2842399513}"/>
+            </a:ext>
+          </a:extLst>
+        </p:cNvPr>
+        <p:cNvGrpSpPr/>
+        <p:nvPr/>
+      </p:nvGrpSpPr>
+      <p:grpSpPr>
+        <a:xfrm>
+          <a:off x="0" y="0"/>
+          <a:ext cx="0" cy="0"/>
+          <a:chOff x="0" y="0"/>
+          <a:chExt cx="0" cy="0"/>
+        </a:xfrm>
+      </p:grpSpPr>
+      <p:sp>
+        <p:nvSpPr>
+          <p:cNvPr id="2" name="Textfeld 3">
+            <a:extLst>
+              <a:ext uri="{FF2B5EF4-FFF2-40B4-BE49-F238E27FC236}">
+                <a16:creationId xmlns:a16="http://schemas.microsoft.com/office/drawing/2014/main" id="{15763205-9B74-373C-E5B8-29DA43E5344E}"/>
+              </a:ext>
+            </a:extLst>
+          </p:cNvPr>
+          <p:cNvSpPr txBox="1"/>
+          <p:nvPr/>
+        </p:nvSpPr>
+        <p:spPr>
+          <a:xfrm>
+            <a:off x="1314628" y="456623"/>
+            <a:ext cx="9283883" cy="6131102"/>
+          </a:xfrm>
+          <a:prstGeom prst="rect">
+            <a:avLst/>
+          </a:prstGeom>
+          <a:noFill/>
+        </p:spPr>
+        <p:txBody>
+          <a:bodyPr wrap="square" lIns="0" tIns="0" rIns="0" bIns="0" rtlCol="0">
+            <a:spAutoFit/>
+          </a:bodyPr>
+          <a:lstStyle/>
+          <a:p>
+            <a:pPr eaLnBrk="0" hangingPunct="0">
+              <a:lnSpc>
+                <a:spcPct val="120000"/>
+              </a:lnSpc>
+              <a:spcAft>
+                <a:spcPts val="627"/>
+              </a:spcAft>
+              <a:buClr>
+                <a:srgbClr val="9C072D"/>
+              </a:buClr>
+              <a:tabLst>
+                <a:tab pos="392682" algn="l"/>
+              </a:tabLst>
+            </a:pPr>
+            <a:r>
+              <a:rPr lang="en-GB" sz="3200" b="1" noProof="0" dirty="0">
+                <a:solidFill>
+                  <a:srgbClr val="60737F"/>
+                </a:solidFill>
+                <a:latin typeface="Oswald Regular" panose="02000503000000000000" pitchFamily="2" charset="0"/>
+                <a:ea typeface="Milo-Medium"/>
+                <a:cs typeface="Source Sans Pro"/>
+              </a:rPr>
+              <a:t>Task: integrate a simple power supply using </a:t>
+            </a:r>
+            <a:r>
+              <a:rPr lang="en-GB" sz="3200" b="1" noProof="0" dirty="0" err="1">
+                <a:solidFill>
+                  <a:srgbClr val="60737F"/>
+                </a:solidFill>
+                <a:latin typeface="Oswald Regular" panose="02000503000000000000" pitchFamily="2" charset="0"/>
+                <a:ea typeface="Milo-Medium"/>
+                <a:cs typeface="Source Sans Pro"/>
+              </a:rPr>
+              <a:t>StreamDevice</a:t>
+            </a:r>
+            <a:endParaRPr lang="en-GB" sz="3200" b="1" noProof="0" dirty="0">
+              <a:solidFill>
+                <a:srgbClr val="60737F"/>
+              </a:solidFill>
+              <a:latin typeface="Oswald Regular" panose="02000503000000000000" pitchFamily="2" charset="0"/>
+              <a:ea typeface="Milo-Medium"/>
+              <a:cs typeface="Source Sans Pro"/>
+            </a:endParaRPr>
+          </a:p>
+          <a:p>
+            <a:pPr marL="342900" indent="-342900" eaLnBrk="0" hangingPunct="0">
+              <a:lnSpc>
+                <a:spcPct val="120000"/>
+              </a:lnSpc>
+              <a:spcAft>
+                <a:spcPts val="627"/>
+              </a:spcAft>
+              <a:buClr>
+                <a:srgbClr val="C7DE37"/>
+              </a:buClr>
+              <a:buFont typeface="Arial" panose="020B0604020202020204" pitchFamily="34" charset="0"/>
+              <a:buChar char="•"/>
+              <a:tabLst>
+                <a:tab pos="392682" algn="l"/>
+              </a:tabLst>
+            </a:pPr>
+            <a:r>
+              <a:rPr lang="en-GB" sz="2400" dirty="0">
+                <a:solidFill>
+                  <a:srgbClr val="60737F"/>
+                </a:solidFill>
+                <a:latin typeface="Source Sans Pro"/>
+                <a:ea typeface="Milo-Medium"/>
+                <a:cs typeface="Source Sans Pro"/>
+              </a:rPr>
+              <a:t>Starting the IOC:</a:t>
+            </a:r>
+          </a:p>
+          <a:p>
+            <a:pPr marL="800100" lvl="1" indent="-342900" eaLnBrk="0" hangingPunct="0">
+              <a:lnSpc>
+                <a:spcPct val="120000"/>
+              </a:lnSpc>
+              <a:spcAft>
+                <a:spcPts val="627"/>
+              </a:spcAft>
+              <a:buClr>
+                <a:srgbClr val="C7DE37"/>
+              </a:buClr>
+              <a:buFont typeface="Arial" panose="020B0604020202020204" pitchFamily="34" charset="0"/>
+              <a:buChar char="•"/>
+              <a:tabLst>
+                <a:tab pos="392682" algn="l"/>
+              </a:tabLst>
+            </a:pPr>
+            <a:r>
+              <a:rPr lang="en-GB" sz="2400" noProof="0" dirty="0">
+                <a:solidFill>
+                  <a:srgbClr val="60737F"/>
+                </a:solidFill>
+                <a:latin typeface="Source Sans Pro"/>
+                <a:ea typeface="Milo-Medium"/>
+                <a:cs typeface="Source Sans Pro"/>
+              </a:rPr>
+              <a:t>Change to the directory “</a:t>
+            </a:r>
+            <a:r>
+              <a:rPr lang="en-GB" sz="2400" noProof="0" dirty="0" err="1">
+                <a:solidFill>
+                  <a:srgbClr val="60737F"/>
+                </a:solidFill>
+                <a:latin typeface="Source Sans Pro"/>
+                <a:ea typeface="Milo-Medium"/>
+                <a:cs typeface="Source Sans Pro"/>
+              </a:rPr>
+              <a:t>streamIoc</a:t>
+            </a:r>
+            <a:r>
+              <a:rPr lang="en-GB" sz="2400" noProof="0" dirty="0">
+                <a:solidFill>
+                  <a:srgbClr val="60737F"/>
+                </a:solidFill>
+                <a:latin typeface="Source Sans Pro"/>
+                <a:ea typeface="Milo-Medium"/>
+                <a:cs typeface="Source Sans Pro"/>
+              </a:rPr>
+              <a:t>/</a:t>
+            </a:r>
+            <a:r>
+              <a:rPr lang="en-GB" sz="2400" noProof="0" dirty="0" err="1">
+                <a:solidFill>
+                  <a:srgbClr val="60737F"/>
+                </a:solidFill>
+                <a:latin typeface="Source Sans Pro"/>
+                <a:ea typeface="Milo-Medium"/>
+                <a:cs typeface="Source Sans Pro"/>
+              </a:rPr>
+              <a:t>iocBoot</a:t>
+            </a:r>
+            <a:r>
+              <a:rPr lang="en-GB" sz="2400" noProof="0" dirty="0">
+                <a:solidFill>
+                  <a:srgbClr val="60737F"/>
+                </a:solidFill>
+                <a:latin typeface="Source Sans Pro"/>
+                <a:ea typeface="Milo-Medium"/>
+                <a:cs typeface="Source Sans Pro"/>
+              </a:rPr>
+              <a:t>/</a:t>
+            </a:r>
+            <a:r>
+              <a:rPr lang="en-GB" sz="2400" noProof="0" dirty="0" err="1">
+                <a:solidFill>
+                  <a:srgbClr val="60737F"/>
+                </a:solidFill>
+                <a:latin typeface="Source Sans Pro"/>
+                <a:ea typeface="Milo-Medium"/>
+                <a:cs typeface="Source Sans Pro"/>
+              </a:rPr>
+              <a:t>ioctestIoc</a:t>
+            </a:r>
+            <a:r>
+              <a:rPr lang="en-GB" sz="2400" noProof="0" dirty="0">
+                <a:solidFill>
+                  <a:srgbClr val="60737F"/>
+                </a:solidFill>
+                <a:latin typeface="Source Sans Pro"/>
+                <a:ea typeface="Milo-Medium"/>
+                <a:cs typeface="Source Sans Pro"/>
+              </a:rPr>
+              <a:t>”</a:t>
+            </a:r>
+          </a:p>
+          <a:p>
+            <a:pPr marL="1257300" lvl="2" indent="-342900" eaLnBrk="0" hangingPunct="0">
+              <a:lnSpc>
+                <a:spcPct val="120000"/>
+              </a:lnSpc>
+              <a:spcAft>
+                <a:spcPts val="627"/>
+              </a:spcAft>
+              <a:buClr>
+                <a:srgbClr val="C7DE37"/>
+              </a:buClr>
+              <a:buFont typeface="Arial" panose="020B0604020202020204" pitchFamily="34" charset="0"/>
+              <a:buChar char="•"/>
+              <a:tabLst>
+                <a:tab pos="392682" algn="l"/>
+              </a:tabLst>
+            </a:pPr>
+            <a:r>
+              <a:rPr lang="en-GB" sz="2000" dirty="0">
+                <a:solidFill>
+                  <a:srgbClr val="60737F"/>
+                </a:solidFill>
+                <a:latin typeface="Source Sans Pro"/>
+                <a:ea typeface="Milo-Medium"/>
+                <a:cs typeface="Source Sans Pro"/>
+              </a:rPr>
+              <a:t>It would be good to take a look at the directory structure</a:t>
+            </a:r>
+          </a:p>
+          <a:p>
+            <a:pPr marL="800100" lvl="1" indent="-342900" eaLnBrk="0" hangingPunct="0">
+              <a:lnSpc>
+                <a:spcPct val="120000"/>
+              </a:lnSpc>
+              <a:spcAft>
+                <a:spcPts val="627"/>
+              </a:spcAft>
+              <a:buClr>
+                <a:srgbClr val="C7DE37"/>
+              </a:buClr>
+              <a:buFont typeface="Arial" panose="020B0604020202020204" pitchFamily="34" charset="0"/>
+              <a:buChar char="•"/>
+              <a:tabLst>
+                <a:tab pos="392682" algn="l"/>
+              </a:tabLst>
+            </a:pPr>
+            <a:r>
+              <a:rPr lang="en-GB" sz="2400" noProof="0" dirty="0">
+                <a:solidFill>
+                  <a:srgbClr val="60737F"/>
+                </a:solidFill>
+                <a:latin typeface="Source Sans Pro"/>
+                <a:ea typeface="Milo-Medium"/>
+                <a:cs typeface="Source Sans Pro"/>
+              </a:rPr>
+              <a:t>Start the IOC with the command ./</a:t>
+            </a:r>
+            <a:r>
+              <a:rPr lang="en-GB" sz="2400" noProof="0" dirty="0" err="1">
+                <a:solidFill>
+                  <a:srgbClr val="60737F"/>
+                </a:solidFill>
+                <a:latin typeface="Source Sans Pro"/>
+                <a:ea typeface="Milo-Medium"/>
+                <a:cs typeface="Source Sans Pro"/>
+              </a:rPr>
+              <a:t>st.cmd</a:t>
+            </a:r>
+            <a:endParaRPr lang="en-GB" sz="2400" noProof="0" dirty="0">
+              <a:solidFill>
+                <a:srgbClr val="60737F"/>
+              </a:solidFill>
+              <a:latin typeface="Source Sans Pro"/>
+              <a:ea typeface="Milo-Medium"/>
+              <a:cs typeface="Source Sans Pro"/>
+            </a:endParaRPr>
+          </a:p>
+          <a:p>
+            <a:pPr marL="1257300" lvl="2" indent="-342900" eaLnBrk="0" hangingPunct="0">
+              <a:lnSpc>
+                <a:spcPct val="120000"/>
+              </a:lnSpc>
+              <a:spcAft>
+                <a:spcPts val="627"/>
+              </a:spcAft>
+              <a:buClr>
+                <a:srgbClr val="C7DE37"/>
+              </a:buClr>
+              <a:buFont typeface="Arial" panose="020B0604020202020204" pitchFamily="34" charset="0"/>
+              <a:buChar char="•"/>
+              <a:tabLst>
+                <a:tab pos="392682" algn="l"/>
+              </a:tabLst>
+            </a:pPr>
+            <a:r>
+              <a:rPr lang="en-GB" sz="2400" noProof="0" dirty="0">
+                <a:solidFill>
+                  <a:srgbClr val="60737F"/>
+                </a:solidFill>
+                <a:latin typeface="Source Sans Pro"/>
+                <a:ea typeface="Milo-Medium"/>
+                <a:cs typeface="Source Sans Pro"/>
+              </a:rPr>
+              <a:t>Pay attention</a:t>
+            </a:r>
+            <a:r>
+              <a:rPr lang="en-GB" sz="2400" dirty="0">
+                <a:solidFill>
+                  <a:srgbClr val="60737F"/>
+                </a:solidFill>
+                <a:latin typeface="Source Sans Pro"/>
+                <a:ea typeface="Milo-Medium"/>
+                <a:cs typeface="Source Sans Pro"/>
+              </a:rPr>
+              <a:t> to the terminal output.</a:t>
+            </a:r>
+          </a:p>
+          <a:p>
+            <a:pPr marL="800100" lvl="1" indent="-342900" eaLnBrk="0" hangingPunct="0">
+              <a:lnSpc>
+                <a:spcPct val="120000"/>
+              </a:lnSpc>
+              <a:spcAft>
+                <a:spcPts val="627"/>
+              </a:spcAft>
+              <a:buClr>
+                <a:srgbClr val="C7DE37"/>
+              </a:buClr>
+              <a:buFont typeface="Arial" panose="020B0604020202020204" pitchFamily="34" charset="0"/>
+              <a:buChar char="•"/>
+              <a:tabLst>
+                <a:tab pos="392682" algn="l"/>
+              </a:tabLst>
+            </a:pPr>
+            <a:r>
+              <a:rPr lang="en-GB" sz="2400" noProof="0" dirty="0">
+                <a:solidFill>
+                  <a:srgbClr val="60737F"/>
+                </a:solidFill>
+                <a:latin typeface="Source Sans Pro"/>
+                <a:ea typeface="Milo-Medium"/>
+                <a:cs typeface="Source Sans Pro"/>
+              </a:rPr>
+              <a:t>The IOC </a:t>
+            </a:r>
+            <a:r>
+              <a:rPr lang="en-GB" sz="2400" dirty="0">
+                <a:solidFill>
+                  <a:srgbClr val="60737F"/>
+                </a:solidFill>
+                <a:latin typeface="Source Sans Pro"/>
+                <a:ea typeface="Milo-Medium"/>
+                <a:cs typeface="Source Sans Pro"/>
+              </a:rPr>
+              <a:t>serves a number of records in addition to the PSU simulation. </a:t>
+            </a:r>
+          </a:p>
+          <a:p>
+            <a:pPr marL="1257300" lvl="2" indent="-342900" eaLnBrk="0" hangingPunct="0">
+              <a:lnSpc>
+                <a:spcPct val="120000"/>
+              </a:lnSpc>
+              <a:spcAft>
+                <a:spcPts val="627"/>
+              </a:spcAft>
+              <a:buClr>
+                <a:srgbClr val="C7DE37"/>
+              </a:buClr>
+              <a:buFont typeface="Arial" panose="020B0604020202020204" pitchFamily="34" charset="0"/>
+              <a:buChar char="•"/>
+              <a:tabLst>
+                <a:tab pos="392682" algn="l"/>
+              </a:tabLst>
+            </a:pPr>
+            <a:r>
+              <a:rPr lang="en-GB" sz="2400" noProof="0" dirty="0">
+                <a:solidFill>
+                  <a:srgbClr val="60737F"/>
+                </a:solidFill>
+                <a:latin typeface="Source Sans Pro"/>
+                <a:ea typeface="Milo-Medium"/>
+                <a:cs typeface="Source Sans Pro"/>
+              </a:rPr>
+              <a:t>Let us look at the startup script (</a:t>
+            </a:r>
+            <a:r>
+              <a:rPr lang="en-GB" sz="2400" noProof="0" dirty="0" err="1">
+                <a:solidFill>
+                  <a:srgbClr val="60737F"/>
+                </a:solidFill>
+                <a:latin typeface="Source Sans Pro"/>
+                <a:ea typeface="Milo-Medium"/>
+                <a:cs typeface="Source Sans Pro"/>
+              </a:rPr>
+              <a:t>st.cmd</a:t>
+            </a:r>
+            <a:r>
+              <a:rPr lang="en-GB" sz="2400" noProof="0" dirty="0">
+                <a:solidFill>
+                  <a:srgbClr val="60737F"/>
+                </a:solidFill>
+                <a:latin typeface="Source Sans Pro"/>
+                <a:ea typeface="Milo-Medium"/>
+                <a:cs typeface="Source Sans Pro"/>
+              </a:rPr>
+              <a:t>)</a:t>
+            </a:r>
+            <a:r>
+              <a:rPr lang="en-GB" sz="2400" dirty="0">
+                <a:solidFill>
+                  <a:srgbClr val="60737F"/>
+                </a:solidFill>
+                <a:latin typeface="Source Sans Pro"/>
+                <a:ea typeface="Milo-Medium"/>
+                <a:cs typeface="Source Sans Pro"/>
+              </a:rPr>
+              <a:t> to see the commands.</a:t>
+            </a:r>
+          </a:p>
+          <a:p>
+            <a:pPr marL="342900" indent="-342900" eaLnBrk="0" hangingPunct="0">
+              <a:lnSpc>
+                <a:spcPct val="120000"/>
+              </a:lnSpc>
+              <a:spcAft>
+                <a:spcPts val="627"/>
+              </a:spcAft>
+              <a:buClr>
+                <a:srgbClr val="C7DE37"/>
+              </a:buClr>
+              <a:buFont typeface="Arial" panose="020B0604020202020204" pitchFamily="34" charset="0"/>
+              <a:buChar char="•"/>
+              <a:tabLst>
+                <a:tab pos="392682" algn="l"/>
+              </a:tabLst>
+            </a:pPr>
+            <a:r>
+              <a:rPr lang="en-GB" sz="2400" noProof="0" dirty="0">
+                <a:solidFill>
+                  <a:srgbClr val="60737F"/>
+                </a:solidFill>
+                <a:latin typeface="Source Sans Pro"/>
+                <a:ea typeface="Milo-Medium"/>
+                <a:cs typeface="Source Sans Pro"/>
+              </a:rPr>
+              <a:t>In another window, type “</a:t>
+            </a:r>
+            <a:r>
+              <a:rPr lang="en-GB" sz="2400" noProof="0" dirty="0" err="1">
+                <a:solidFill>
+                  <a:srgbClr val="60737F"/>
+                </a:solidFill>
+                <a:latin typeface="Source Sans Pro"/>
+                <a:ea typeface="Milo-Medium"/>
+                <a:cs typeface="Source Sans Pro"/>
+              </a:rPr>
+              <a:t>pvget</a:t>
+            </a:r>
+            <a:r>
+              <a:rPr lang="en-GB" sz="2400" noProof="0" dirty="0">
+                <a:solidFill>
+                  <a:srgbClr val="60737F"/>
+                </a:solidFill>
+                <a:latin typeface="Source Sans Pro"/>
+                <a:ea typeface="Milo-Medium"/>
+                <a:cs typeface="Source Sans Pro"/>
+              </a:rPr>
+              <a:t> </a:t>
+            </a:r>
+            <a:r>
+              <a:rPr lang="en-GB" sz="2400" noProof="0" dirty="0" err="1">
+                <a:solidFill>
+                  <a:srgbClr val="60737F"/>
+                </a:solidFill>
+                <a:latin typeface="Source Sans Pro"/>
+                <a:ea typeface="Milo-Medium"/>
+                <a:cs typeface="Source Sans Pro"/>
+              </a:rPr>
+              <a:t>epics-dev:IDN</a:t>
+            </a:r>
+            <a:r>
+              <a:rPr lang="en-GB" sz="2400" noProof="0" dirty="0">
+                <a:solidFill>
+                  <a:srgbClr val="60737F"/>
+                </a:solidFill>
+                <a:latin typeface="Source Sans Pro"/>
+                <a:ea typeface="Milo-Medium"/>
+                <a:cs typeface="Source Sans Pro"/>
+              </a:rPr>
+              <a:t>” and check the reply.</a:t>
+            </a:r>
+          </a:p>
+          <a:p>
+            <a:pPr marL="800100" lvl="1" indent="-342900" eaLnBrk="0" hangingPunct="0">
+              <a:lnSpc>
+                <a:spcPct val="120000"/>
+              </a:lnSpc>
+              <a:spcAft>
+                <a:spcPts val="627"/>
+              </a:spcAft>
+              <a:buClr>
+                <a:srgbClr val="C7DE37"/>
+              </a:buClr>
+              <a:buFont typeface="Arial" panose="020B0604020202020204" pitchFamily="34" charset="0"/>
+              <a:buChar char="•"/>
+              <a:tabLst>
+                <a:tab pos="392682" algn="l"/>
+              </a:tabLst>
+            </a:pPr>
+            <a:r>
+              <a:rPr lang="en-GB" sz="2400" noProof="0" dirty="0">
+                <a:solidFill>
+                  <a:srgbClr val="60737F"/>
+                </a:solidFill>
+                <a:latin typeface="Source Sans Pro"/>
+                <a:ea typeface="Milo-Medium"/>
+                <a:cs typeface="Source Sans Pro"/>
+              </a:rPr>
+              <a:t>If you get a reply and no timeout, congratulations!</a:t>
+            </a:r>
+          </a:p>
+          <a:p>
+            <a:pPr marL="342900" indent="-342900" eaLnBrk="0" hangingPunct="0">
+              <a:lnSpc>
+                <a:spcPct val="120000"/>
+              </a:lnSpc>
+              <a:spcAft>
+                <a:spcPts val="627"/>
+              </a:spcAft>
+              <a:buClr>
+                <a:srgbClr val="C7DE37"/>
+              </a:buClr>
+              <a:buFont typeface="Arial" panose="020B0604020202020204" pitchFamily="34" charset="0"/>
+              <a:buChar char="•"/>
+              <a:tabLst>
+                <a:tab pos="392682" algn="l"/>
+              </a:tabLst>
+            </a:pPr>
+            <a:r>
+              <a:rPr lang="en-GB" sz="2400" dirty="0">
+                <a:solidFill>
+                  <a:srgbClr val="60737F"/>
+                </a:solidFill>
+                <a:latin typeface="Source Sans Pro"/>
+                <a:ea typeface="Milo-Medium"/>
+                <a:cs typeface="Source Sans Pro"/>
+              </a:rPr>
+              <a:t>Next, let us examine the protocol file and the EPICS database.</a:t>
+            </a:r>
+            <a:endParaRPr lang="en-GB" sz="2400" noProof="0" dirty="0">
+              <a:solidFill>
+                <a:srgbClr val="60737F"/>
+              </a:solidFill>
+              <a:latin typeface="Source Sans Pro"/>
+              <a:ea typeface="Milo-Medium"/>
+              <a:cs typeface="Source Sans Pro"/>
+            </a:endParaRPr>
+          </a:p>
+        </p:txBody>
+      </p:sp>
+    </p:spTree>
+    <p:extLst>
+      <p:ext uri="{BB962C8B-B14F-4D97-AF65-F5344CB8AC3E}">
+        <p14:creationId xmlns:p14="http://schemas.microsoft.com/office/powerpoint/2010/main" val="1869742673"/>
       </p:ext>
     </p:extLst>
   </p:cSld>
@@ -7260,7 +7728,7 @@
         <p:cNvPr id="1" name="">
           <a:extLst>
             <a:ext uri="{FF2B5EF4-FFF2-40B4-BE49-F238E27FC236}">
-              <a16:creationId xmlns:a16="http://schemas.microsoft.com/office/drawing/2014/main" id="{CB5A8C0B-B17A-2F4F-CB49-FF2842399513}"/>
+              <a16:creationId xmlns:a16="http://schemas.microsoft.com/office/drawing/2014/main" id="{A877ED4F-0CD0-7C29-C8C6-1FA6AE26F771}"/>
             </a:ext>
           </a:extLst>
         </p:cNvPr>
@@ -7280,7 +7748,7 @@
           <p:cNvPr id="2" name="Textfeld 3">
             <a:extLst>
               <a:ext uri="{FF2B5EF4-FFF2-40B4-BE49-F238E27FC236}">
-                <a16:creationId xmlns:a16="http://schemas.microsoft.com/office/drawing/2014/main" id="{15763205-9B74-373C-E5B8-29DA43E5344E}"/>
+                <a16:creationId xmlns:a16="http://schemas.microsoft.com/office/drawing/2014/main" id="{48DD60DD-4433-832A-0D2A-7A89708D1FD2}"/>
               </a:ext>
             </a:extLst>
           </p:cNvPr>
@@ -7290,7 +7758,7 @@
         <p:spPr>
           <a:xfrm>
             <a:off x="1314628" y="456623"/>
-            <a:ext cx="9283883" cy="6131102"/>
+            <a:ext cx="9283883" cy="4201343"/>
           </a:xfrm>
           <a:prstGeom prst="rect">
             <a:avLst/>
@@ -7318,7 +7786,7 @@
               </a:tabLst>
             </a:pPr>
             <a:r>
-              <a:rPr lang="en-GB" sz="3200" b="1" noProof="0" dirty="0">
+              <a:rPr lang="en-GB" sz="3200" b="1" dirty="0">
                 <a:solidFill>
                   <a:srgbClr val="60737F"/>
                 </a:solidFill>
@@ -7326,18 +7794,7 @@
                 <a:ea typeface="Milo-Medium"/>
                 <a:cs typeface="Source Sans Pro"/>
               </a:rPr>
-              <a:t>Task: integrate a simple power supply using </a:t>
-            </a:r>
-            <a:r>
-              <a:rPr lang="en-GB" sz="3200" b="1" noProof="0" dirty="0" err="1">
-                <a:solidFill>
-                  <a:srgbClr val="60737F"/>
-                </a:solidFill>
-                <a:latin typeface="Oswald Regular" panose="02000503000000000000" pitchFamily="2" charset="0"/>
-                <a:ea typeface="Milo-Medium"/>
-                <a:cs typeface="Source Sans Pro"/>
-              </a:rPr>
-              <a:t>StreamDevice</a:t>
+              <a:t>Optional: Create a simple Phoebus OPI</a:t>
             </a:r>
             <a:endParaRPr lang="en-GB" sz="3200" b="1" noProof="0" dirty="0">
               <a:solidFill>
@@ -7374,7 +7831,98 @@
                 <a:ea typeface="Milo-Medium"/>
                 <a:cs typeface="Source Sans Pro"/>
               </a:rPr>
-              <a:t>Starting the IOC:</a:t>
+              <a:t>Start the IOC, if not running.</a:t>
+            </a:r>
+          </a:p>
+          <a:p>
+            <a:pPr marL="342900" indent="-342900" eaLnBrk="0" hangingPunct="0">
+              <a:lnSpc>
+                <a:spcPct val="120000"/>
+              </a:lnSpc>
+              <a:spcAft>
+                <a:spcPts val="627"/>
+              </a:spcAft>
+              <a:buClr>
+                <a:srgbClr val="C7DE37"/>
+              </a:buClr>
+              <a:buFont typeface="Arial" panose="020B0604020202020204" pitchFamily="34" charset="0"/>
+              <a:buChar char="•"/>
+              <a:tabLst>
+                <a:tab pos="392682" algn="l"/>
+              </a:tabLst>
+            </a:pPr>
+            <a:r>
+              <a:rPr lang="en-GB" sz="2400" dirty="0">
+                <a:solidFill>
+                  <a:srgbClr val="60737F"/>
+                </a:solidFill>
+                <a:latin typeface="Source Sans Pro"/>
+                <a:ea typeface="Milo-Medium"/>
+                <a:cs typeface="Source Sans Pro"/>
+              </a:rPr>
+              <a:t>Next, start Phoebus. Let us work interactively from here.</a:t>
+            </a:r>
+          </a:p>
+          <a:p>
+            <a:pPr marL="342900" indent="-342900" eaLnBrk="0" hangingPunct="0">
+              <a:lnSpc>
+                <a:spcPct val="120000"/>
+              </a:lnSpc>
+              <a:spcAft>
+                <a:spcPts val="627"/>
+              </a:spcAft>
+              <a:buClr>
+                <a:srgbClr val="C7DE37"/>
+              </a:buClr>
+              <a:buFont typeface="Arial" panose="020B0604020202020204" pitchFamily="34" charset="0"/>
+              <a:buChar char="•"/>
+              <a:tabLst>
+                <a:tab pos="392682" algn="l"/>
+              </a:tabLst>
+            </a:pPr>
+            <a:r>
+              <a:rPr lang="en-GB" sz="2400" dirty="0">
+                <a:solidFill>
+                  <a:srgbClr val="60737F"/>
+                </a:solidFill>
+                <a:latin typeface="Source Sans Pro"/>
+                <a:ea typeface="Milo-Medium"/>
+                <a:cs typeface="Source Sans Pro"/>
+              </a:rPr>
+              <a:t>Task is to c</a:t>
+            </a:r>
+            <a:r>
+              <a:rPr lang="en-GB" sz="2400" noProof="0" dirty="0" err="1">
+                <a:solidFill>
+                  <a:srgbClr val="60737F"/>
+                </a:solidFill>
+                <a:latin typeface="Source Sans Pro"/>
+                <a:ea typeface="Milo-Medium"/>
+                <a:cs typeface="Source Sans Pro"/>
+              </a:rPr>
+              <a:t>reate</a:t>
+            </a:r>
+            <a:r>
+              <a:rPr lang="en-GB" sz="2400" noProof="0" dirty="0">
+                <a:solidFill>
+                  <a:srgbClr val="60737F"/>
+                </a:solidFill>
+                <a:latin typeface="Source Sans Pro"/>
+                <a:ea typeface="Milo-Medium"/>
+                <a:cs typeface="Source Sans Pro"/>
+              </a:rPr>
+              <a:t> a</a:t>
+            </a:r>
+            <a:r>
+              <a:rPr lang="en-GB" sz="2400" dirty="0">
+                <a:solidFill>
+                  <a:srgbClr val="60737F"/>
+                </a:solidFill>
+                <a:latin typeface="Source Sans Pro"/>
+                <a:ea typeface="Milo-Medium"/>
+                <a:cs typeface="Source Sans Pro"/>
+              </a:rPr>
+              <a:t>n OPI with:</a:t>
             </a:r>
           </a:p>
           <a:p>
@@ -7403,102 +7951,7 @@
                 <a:ea typeface="Milo-Medium"/>
                 <a:cs typeface="Source Sans Pro"/>
               </a:rPr>
-              <a:t>Change to the directory “</a:t>
-            </a:r>
-            <a:r>
-              <a:rPr lang="en-GB" sz="2400" noProof="0" dirty="0" err="1">
-                <a:solidFill>
-                  <a:srgbClr val="60737F"/>
-                </a:solidFill>
-                <a:latin typeface="Source Sans Pro"/>
-                <a:ea typeface="Milo-Medium"/>
-                <a:cs typeface="Source Sans Pro"/>
-              </a:rPr>
-              <a:t>streamIoc</a:t>
-            </a:r>
-            <a:r>
-              <a:rPr lang="en-GB" sz="2400" noProof="0" dirty="0">
-                <a:solidFill>
-                  <a:srgbClr val="60737F"/>
-                </a:solidFill>
-                <a:latin typeface="Source Sans Pro"/>
-                <a:ea typeface="Milo-Medium"/>
-                <a:cs typeface="Source Sans Pro"/>
-              </a:rPr>
-              <a:t>/</a:t>
-            </a:r>
-            <a:r>
-              <a:rPr lang="en-GB" sz="2400" noProof="0" dirty="0" err="1">
-                <a:solidFill>
-                  <a:srgbClr val="60737F"/>
-                </a:solidFill>
-                <a:latin typeface="Source Sans Pro"/>
-                <a:ea typeface="Milo-Medium"/>
-                <a:cs typeface="Source Sans Pro"/>
-              </a:rPr>
-              <a:t>iocBoot</a:t>
-            </a:r>
-            <a:r>
-              <a:rPr lang="en-GB" sz="2400" noProof="0" dirty="0">
-                <a:solidFill>
-                  <a:srgbClr val="60737F"/>
-                </a:solidFill>
-                <a:latin typeface="Source Sans Pro"/>
-                <a:ea typeface="Milo-Medium"/>
-                <a:cs typeface="Source Sans Pro"/>
-              </a:rPr>
-              <a:t>/</a:t>
-            </a:r>
-            <a:r>
-              <a:rPr lang="en-GB" sz="2400" noProof="0" dirty="0" err="1">
-                <a:solidFill>
-                  <a:srgbClr val="60737F"/>
-                </a:solidFill>
-                <a:latin typeface="Source Sans Pro"/>
-                <a:ea typeface="Milo-Medium"/>
-                <a:cs typeface="Source Sans Pro"/>
-              </a:rPr>
-              <a:t>ioctestIoc</a:t>
-            </a:r>
-            <a:r>
-              <a:rPr lang="en-GB" sz="2400" noProof="0" dirty="0">
-                <a:solidFill>
-                  <a:srgbClr val="60737F"/>
-                </a:solidFill>
-                <a:latin typeface="Source Sans Pro"/>
-                <a:ea typeface="Milo-Medium"/>
-                <a:cs typeface="Source Sans Pro"/>
-              </a:rPr>
-              <a:t>”</a:t>
-            </a:r>
-          </a:p>
-          <a:p>
-            <a:pPr marL="1257300" lvl="2" indent="-342900" eaLnBrk="0" hangingPunct="0">
-              <a:lnSpc>
-                <a:spcPct val="120000"/>
-              </a:lnSpc>
-              <a:spcAft>
-                <a:spcPts val="627"/>
-              </a:spcAft>
-              <a:buClr>
-                <a:srgbClr val="C7DE37"/>
-              </a:buClr>
-              <a:buFont typeface="Arial" panose="020B0604020202020204" pitchFamily="34" charset="0"/>
-              <a:buChar char="•"/>
-              <a:tabLst>
-                <a:tab pos="392682" algn="l"/>
-              </a:tabLst>
-            </a:pPr>
-            <a:r>
-              <a:rPr lang="en-GB" sz="2000" dirty="0">
-                <a:solidFill>
-                  <a:srgbClr val="60737F"/>
-                </a:solidFill>
-                <a:latin typeface="Source Sans Pro"/>
-                <a:ea typeface="Milo-Medium"/>
-                <a:cs typeface="Source Sans Pro"/>
-              </a:rPr>
-              <a:t>It would be good to take a look at the directory structure</a:t>
+              <a:t>A button to switch on and off the power supply</a:t>
             </a:r>
           </a:p>
           <a:p>
@@ -7519,7 +7972,7 @@
               </a:tabLst>
             </a:pPr>
             <a:r>
-              <a:rPr lang="en-GB" sz="2400" noProof="0" dirty="0">
+              <a:rPr lang="en-GB" sz="2400" dirty="0">
                 <a:solidFill>
                   <a:srgbClr val="60737F"/>
                 </a:solidFill>
@@ -7527,66 +7980,7 @@
                 <a:ea typeface="Milo-Medium"/>
                 <a:cs typeface="Source Sans Pro"/>
               </a:rPr>
-              <a:t>Start the IOC with the command ./</a:t>
-            </a:r>
-            <a:r>
-              <a:rPr lang="en-GB" sz="2400" noProof="0" dirty="0" err="1">
-                <a:solidFill>
-                  <a:srgbClr val="60737F"/>
-                </a:solidFill>
-                <a:latin typeface="Source Sans Pro"/>
-                <a:ea typeface="Milo-Medium"/>
-                <a:cs typeface="Source Sans Pro"/>
-              </a:rPr>
-              <a:t>st.cmd</a:t>
-            </a:r>
-            <a:endParaRPr lang="en-GB" sz="2400" noProof="0" dirty="0">
-              <a:solidFill>
-                <a:srgbClr val="60737F"/>
-              </a:solidFill>
-              <a:latin typeface="Source Sans Pro"/>
-              <a:ea typeface="Milo-Medium"/>
-              <a:cs typeface="Source Sans Pro"/>
-            </a:endParaRPr>
-          </a:p>
-          <a:p>
-            <a:pPr marL="1257300" lvl="2" indent="-342900" eaLnBrk="0" hangingPunct="0">
-              <a:lnSpc>
-                <a:spcPct val="120000"/>
-              </a:lnSpc>
-              <a:spcAft>
-                <a:spcPts val="627"/>
-              </a:spcAft>
-              <a:buClr>
-                <a:srgbClr val="C7DE37"/>
-              </a:buClr>
-              <a:buFont typeface="Arial" panose="020B0604020202020204" pitchFamily="34" charset="0"/>
-              <a:buChar char="•"/>
-              <a:tabLst>
-                <a:tab pos="392682" algn="l"/>
-              </a:tabLst>
-            </a:pPr>
-            <a:r>
-              <a:rPr lang="en-GB" sz="2400" noProof="0" dirty="0">
-                <a:solidFill>
-                  <a:srgbClr val="60737F"/>
-                </a:solidFill>
-                <a:latin typeface="Source Sans Pro"/>
-                <a:ea typeface="Milo-Medium"/>
-                <a:cs typeface="Source Sans Pro"/>
-              </a:rPr>
-              <a:t>Pay attention</a:t>
-            </a:r>
-            <a:r>
-              <a:rPr lang="en-GB" sz="2400" dirty="0">
-                <a:solidFill>
-                  <a:srgbClr val="60737F"/>
-                </a:solidFill>
-                <a:latin typeface="Source Sans Pro"/>
-                <a:ea typeface="Milo-Medium"/>
-                <a:cs typeface="Source Sans Pro"/>
-              </a:rPr>
-              <a:t> to the terminal output.</a:t>
+              <a:t>A monitor widget (LED) to display the power supply status</a:t>
             </a:r>
           </a:p>
           <a:p>
@@ -7607,7 +8001,7 @@
               </a:tabLst>
             </a:pPr>
             <a:r>
-              <a:rPr lang="en-GB" sz="2400" noProof="0" dirty="0">
+              <a:rPr lang="en-GB" sz="2400" dirty="0">
                 <a:solidFill>
                   <a:srgbClr val="60737F"/>
                 </a:solidFill>
@@ -7615,153 +8009,7 @@
                 <a:ea typeface="Milo-Medium"/>
                 <a:cs typeface="Source Sans Pro"/>
               </a:rPr>
-              <a:t>The IOC </a:t>
-            </a:r>
-            <a:r>
-              <a:rPr lang="en-GB" sz="2400" dirty="0">
-                <a:solidFill>
-                  <a:srgbClr val="60737F"/>
-                </a:solidFill>
-                <a:latin typeface="Source Sans Pro"/>
-                <a:ea typeface="Milo-Medium"/>
-                <a:cs typeface="Source Sans Pro"/>
-              </a:rPr>
-              <a:t>serves a number of records in addition to the PSU simulation. </a:t>
-            </a:r>
-          </a:p>
-          <a:p>
-            <a:pPr marL="1257300" lvl="2" indent="-342900" eaLnBrk="0" hangingPunct="0">
-              <a:lnSpc>
-                <a:spcPct val="120000"/>
-              </a:lnSpc>
-              <a:spcAft>
-                <a:spcPts val="627"/>
-              </a:spcAft>
-              <a:buClr>
-                <a:srgbClr val="C7DE37"/>
-              </a:buClr>
-              <a:buFont typeface="Arial" panose="020B0604020202020204" pitchFamily="34" charset="0"/>
-              <a:buChar char="•"/>
-              <a:tabLst>
-                <a:tab pos="392682" algn="l"/>
-              </a:tabLst>
-            </a:pPr>
-            <a:r>
-              <a:rPr lang="en-GB" sz="2400" noProof="0" dirty="0">
-                <a:solidFill>
-                  <a:srgbClr val="60737F"/>
-                </a:solidFill>
-                <a:latin typeface="Source Sans Pro"/>
-                <a:ea typeface="Milo-Medium"/>
-                <a:cs typeface="Source Sans Pro"/>
-              </a:rPr>
-              <a:t>Let us look at the startup script (</a:t>
-            </a:r>
-            <a:r>
-              <a:rPr lang="en-GB" sz="2400" noProof="0" dirty="0" err="1">
-                <a:solidFill>
-                  <a:srgbClr val="60737F"/>
-                </a:solidFill>
-                <a:latin typeface="Source Sans Pro"/>
-                <a:ea typeface="Milo-Medium"/>
-                <a:cs typeface="Source Sans Pro"/>
-              </a:rPr>
-              <a:t>st.cmd</a:t>
-            </a:r>
-            <a:r>
-              <a:rPr lang="en-GB" sz="2400" noProof="0" dirty="0">
-                <a:solidFill>
-                  <a:srgbClr val="60737F"/>
-                </a:solidFill>
-                <a:latin typeface="Source Sans Pro"/>
-                <a:ea typeface="Milo-Medium"/>
-                <a:cs typeface="Source Sans Pro"/>
-              </a:rPr>
-              <a:t>)</a:t>
-            </a:r>
-            <a:r>
-              <a:rPr lang="en-GB" sz="2400" dirty="0">
-                <a:solidFill>
-                  <a:srgbClr val="60737F"/>
-                </a:solidFill>
-                <a:latin typeface="Source Sans Pro"/>
-                <a:ea typeface="Milo-Medium"/>
-                <a:cs typeface="Source Sans Pro"/>
-              </a:rPr>
-              <a:t> to see the commands.</a:t>
-            </a:r>
-          </a:p>
-          <a:p>
-            <a:pPr marL="342900" indent="-342900" eaLnBrk="0" hangingPunct="0">
-              <a:lnSpc>
-                <a:spcPct val="120000"/>
-              </a:lnSpc>
-              <a:spcAft>
-                <a:spcPts val="627"/>
-              </a:spcAft>
-              <a:buClr>
-                <a:srgbClr val="C7DE37"/>
-              </a:buClr>
-              <a:buFont typeface="Arial" panose="020B0604020202020204" pitchFamily="34" charset="0"/>
-              <a:buChar char="•"/>
-              <a:tabLst>
-                <a:tab pos="392682" algn="l"/>
-              </a:tabLst>
-            </a:pPr>
-            <a:r>
-              <a:rPr lang="en-GB" sz="2400" noProof="0" dirty="0">
-                <a:solidFill>
-                  <a:srgbClr val="60737F"/>
-                </a:solidFill>
-                <a:latin typeface="Source Sans Pro"/>
-                <a:ea typeface="Milo-Medium"/>
-                <a:cs typeface="Source Sans Pro"/>
-              </a:rPr>
-              <a:t>In another window, type “</a:t>
-            </a:r>
-            <a:r>
-              <a:rPr lang="en-GB" sz="2400" noProof="0" dirty="0" err="1">
-                <a:solidFill>
-                  <a:srgbClr val="60737F"/>
-                </a:solidFill>
-                <a:latin typeface="Source Sans Pro"/>
-                <a:ea typeface="Milo-Medium"/>
-                <a:cs typeface="Source Sans Pro"/>
-              </a:rPr>
-              <a:t>pvget</a:t>
-            </a:r>
-            <a:r>
-              <a:rPr lang="en-GB" sz="2400" noProof="0" dirty="0">
-                <a:solidFill>
-                  <a:srgbClr val="60737F"/>
-                </a:solidFill>
-                <a:latin typeface="Source Sans Pro"/>
-                <a:ea typeface="Milo-Medium"/>
-                <a:cs typeface="Source Sans Pro"/>
-              </a:rPr>
-              <a:t> </a:t>
-            </a:r>
-            <a:r>
-              <a:rPr lang="en-GB" sz="2400" noProof="0" dirty="0" err="1">
-                <a:solidFill>
-                  <a:srgbClr val="60737F"/>
-                </a:solidFill>
-                <a:latin typeface="Source Sans Pro"/>
-                <a:ea typeface="Milo-Medium"/>
-                <a:cs typeface="Source Sans Pro"/>
-              </a:rPr>
-              <a:t>epics-dev:IDN</a:t>
-            </a:r>
-            <a:r>
-              <a:rPr lang="en-GB" sz="2400" noProof="0" dirty="0">
-                <a:solidFill>
-                  <a:srgbClr val="60737F"/>
-                </a:solidFill>
-                <a:latin typeface="Source Sans Pro"/>
-                <a:ea typeface="Milo-Medium"/>
-                <a:cs typeface="Source Sans Pro"/>
-              </a:rPr>
-              <a:t>” and check the reply.</a:t>
+              <a:t>A control widget (text, thumbwheel) to set the output voltage</a:t>
             </a:r>
           </a:p>
           <a:p>
@@ -7790,28 +8038,10 @@
                 <a:ea typeface="Milo-Medium"/>
                 <a:cs typeface="Source Sans Pro"/>
               </a:rPr>
-              <a:t>If you get a reply and no timeout, congratulations!</a:t>
-            </a:r>
-          </a:p>
-          <a:p>
-            <a:pPr marL="342900" indent="-342900" eaLnBrk="0" hangingPunct="0">
-              <a:lnSpc>
-                <a:spcPct val="120000"/>
-              </a:lnSpc>
-              <a:spcAft>
-                <a:spcPts val="627"/>
-              </a:spcAft>
-              <a:buClr>
-                <a:srgbClr val="C7DE37"/>
-              </a:buClr>
-              <a:buFont typeface="Arial" panose="020B0604020202020204" pitchFamily="34" charset="0"/>
-              <a:buChar char="•"/>
-              <a:tabLst>
-                <a:tab pos="392682" algn="l"/>
-              </a:tabLst>
-            </a:pPr>
-            <a:r>
-              <a:rPr lang="en-GB" sz="2400" dirty="0">
+              <a:t>A monitor widget to show the </a:t>
+            </a:r>
+            <a:r>
+              <a:rPr lang="en-GB" sz="2400" noProof="0">
                 <a:solidFill>
                   <a:srgbClr val="60737F"/>
                 </a:solidFill>
@@ -7819,7 +8049,40 @@
                 <a:ea typeface="Milo-Medium"/>
                 <a:cs typeface="Source Sans Pro"/>
               </a:rPr>
-              <a:t>Next, let us start Phoebus. Let us work interactively from here.</a:t>
+              <a:t>(actual) output </a:t>
+            </a:r>
+            <a:r>
+              <a:rPr lang="en-GB" sz="2400" noProof="0" dirty="0">
+                <a:solidFill>
+                  <a:srgbClr val="60737F"/>
+                </a:solidFill>
+                <a:latin typeface="Source Sans Pro"/>
+                <a:ea typeface="Milo-Medium"/>
+                <a:cs typeface="Source Sans Pro"/>
+              </a:rPr>
+              <a:t>vol</a:t>
+            </a:r>
+            <a:r>
+              <a:rPr lang="en-GB" sz="2400" dirty="0" err="1">
+                <a:solidFill>
+                  <a:srgbClr val="60737F"/>
+                </a:solidFill>
+                <a:latin typeface="Source Sans Pro"/>
+                <a:ea typeface="Milo-Medium"/>
+                <a:cs typeface="Source Sans Pro"/>
+              </a:rPr>
+              <a:t>tage</a:t>
+            </a:r>
+            <a:r>
+              <a:rPr lang="en-GB" sz="2400" dirty="0">
+                <a:solidFill>
+                  <a:srgbClr val="60737F"/>
+                </a:solidFill>
+                <a:latin typeface="Source Sans Pro"/>
+                <a:ea typeface="Milo-Medium"/>
+                <a:cs typeface="Source Sans Pro"/>
+              </a:rPr>
+              <a:t>.</a:t>
             </a:r>
             <a:endParaRPr lang="en-GB" sz="2400" noProof="0" dirty="0">
               <a:solidFill>
@@ -7835,7 +8098,7 @@
     </p:spTree>
     <p:extLst>
       <p:ext uri="{BB962C8B-B14F-4D97-AF65-F5344CB8AC3E}">
-        <p14:creationId xmlns:p14="http://schemas.microsoft.com/office/powerpoint/2010/main" val="1869742673"/>
+        <p14:creationId xmlns:p14="http://schemas.microsoft.com/office/powerpoint/2010/main" val="1922422001"/>
       </p:ext>
     </p:extLst>
   </p:cSld>

</xml_diff>

<commit_message>
fix typo: remove extra curly bracket on page 6
</commit_message>
<xml_diff>
--- a/presentations/EPICS IOC setup.pptx
+++ b/presentations/EPICS IOC setup.pptx
@@ -38,14 +38,14 @@
     </p:embeddedFont>
     <p:embeddedFont>
       <p:font typeface="Oswald Regular" panose="02000503000000000000" pitchFamily="2" charset="77"/>
-      <p:regular r:id="rId19"/>
+      <p:regular r:id=""/>
     </p:embeddedFont>
     <p:embeddedFont>
       <p:font typeface="Source Sans Pro" panose="020B0503030403020204" pitchFamily="34" charset="0"/>
-      <p:regular r:id="rId20"/>
-      <p:bold r:id="rId21"/>
-      <p:italic r:id="rId22"/>
-      <p:boldItalic r:id="rId23"/>
+      <p:regular r:id="rId19"/>
+      <p:bold r:id="rId20"/>
+      <p:italic r:id="rId21"/>
+      <p:boldItalic r:id="rId22"/>
     </p:embeddedFont>
   </p:embeddedFontLst>
   <p:defaultTextStyle>
@@ -6840,7 +6840,7 @@
               <a:buNone/>
             </a:pPr>
             <a:r>
-              <a:rPr lang="en-US" sz="1600" dirty="0">
+              <a:rPr lang="en-US" sz="1600">
                 <a:solidFill>
                   <a:schemeClr val="bg1">
                     <a:lumMod val="50000"/>
@@ -6850,24 +6850,15 @@
               </a:rPr>
               <a:t>	}</a:t>
             </a:r>
-          </a:p>
-          <a:p>
-            <a:pPr marL="0" indent="0">
-              <a:buFont typeface="Arial" panose="020B0604020202020204" pitchFamily="34" charset="0"/>
-              <a:buNone/>
-            </a:pPr>
-            <a:r>
-              <a:rPr lang="en-US" sz="1600" dirty="0">
-                <a:solidFill>
-                  <a:schemeClr val="bg1">
-                    <a:lumMod val="50000"/>
-                  </a:schemeClr>
-                </a:solidFill>
-                <a:latin typeface="Consolas" panose="020B0609020204030204" pitchFamily="49" charset="0"/>
-                <a:cs typeface="Consolas" panose="020B0609020204030204" pitchFamily="49" charset="0"/>
-              </a:rPr>
-              <a:t>}</a:t>
-            </a:r>
+            <a:endParaRPr lang="en-US" sz="1600" dirty="0">
+              <a:solidFill>
+                <a:schemeClr val="bg1">
+                  <a:lumMod val="50000"/>
+                </a:schemeClr>
+              </a:solidFill>
+              <a:latin typeface="Consolas" panose="020B0609020204030204" pitchFamily="49" charset="0"/>
+              <a:cs typeface="Consolas" panose="020B0609020204030204" pitchFamily="49" charset="0"/>
+            </a:endParaRPr>
           </a:p>
           <a:p>
             <a:endParaRPr lang="en-US" dirty="0"/>
@@ -8038,29 +8029,7 @@
                 <a:ea typeface="Milo-Medium"/>
                 <a:cs typeface="Source Sans Pro"/>
               </a:rPr>
-              <a:t>A monitor widget to show the </a:t>
-            </a:r>
-            <a:r>
-              <a:rPr lang="en-GB" sz="2400" noProof="0">
-                <a:solidFill>
-                  <a:srgbClr val="60737F"/>
-                </a:solidFill>
-                <a:latin typeface="Source Sans Pro"/>
-                <a:ea typeface="Milo-Medium"/>
-                <a:cs typeface="Source Sans Pro"/>
-              </a:rPr>
-              <a:t>(actual) output </a:t>
-            </a:r>
-            <a:r>
-              <a:rPr lang="en-GB" sz="2400" noProof="0" dirty="0">
-                <a:solidFill>
-                  <a:srgbClr val="60737F"/>
-                </a:solidFill>
-                <a:latin typeface="Source Sans Pro"/>
-                <a:ea typeface="Milo-Medium"/>
-                <a:cs typeface="Source Sans Pro"/>
-              </a:rPr>
-              <a:t>vol</a:t>
+              <a:t>A monitor widget to show the (actual) output vol</a:t>
             </a:r>
             <a:r>
               <a:rPr lang="en-GB" sz="2400" dirty="0" err="1">

</xml_diff>